<commit_message>
telco-customer churn eda added
</commit_message>
<xml_diff>
--- a/arc/ai/piyush-luitel/Presentation_ai_data_science_matplotlib_eda/AI_DataScience_EDA_Presentation.pptx
+++ b/arc/ai/piyush-luitel/Presentation_ai_data_science_matplotlib_eda/AI_DataScience_EDA_Presentation.pptx
@@ -4580,14 +4580,10 @@
           <a:p>
             <a:r>
               <a:rPr lang="en-US" dirty="0"/>
-              <a:t>One-Hot Encoding: Creating new columns indicating the presence or absence of each possible value, suitable for </a:t>
-            </a:r>
-            <a:r>
-              <a:rPr lang="en-US"/>
-              <a:t>nominal </a:t>
-            </a:r>
-            <a:r>
-              <a:rPr lang="en-US" smtClean="0"/>
+              <a:t>One-Hot Encoding: Creating new columns indicating the presence or absence of each possible value, suitable for nominal </a:t>
+            </a:r>
+            <a:r>
+              <a:rPr lang="en-US" dirty="0" smtClean="0"/>
               <a:t>data</a:t>
             </a:r>
             <a:endParaRPr lang="en-US" dirty="0"/>
@@ -4963,6 +4959,13 @@
   <p:clrMapOvr>
     <a:masterClrMapping/>
   </p:clrMapOvr>
+  <p:timing>
+    <p:tnLst>
+      <p:par>
+        <p:cTn id="1" dur="indefinite" restart="never" nodeType="tmRoot"/>
+      </p:par>
+    </p:tnLst>
+  </p:timing>
 </p:sld>
 </file>
 

</xml_diff>